<commit_message>
Update project files: add new scripts and PPT, remove old images
</commit_message>
<xml_diff>
--- a/Ding_Dongxu_President.pptx
+++ b/Ding_Dongxu_President.pptx
@@ -3446,76 +3446,9 @@
           </a:p>
         </p:txBody>
       </p:sp>
-      <p:pic>
-        <p:nvPicPr>
-          <p:cNvPr id="11" name="Picture 10" descr="user_photo_slide1.jpg"/>
-          <p:cNvPicPr>
-            <a:picLocks noChangeAspect="1"/>
-          </p:cNvPicPr>
-          <p:nvPr/>
-        </p:nvPicPr>
-        <p:blipFill>
-          <a:blip r:embed="rId3"/>
-          <a:stretch>
-            <a:fillRect/>
-          </a:stretch>
-        </p:blipFill>
-        <p:spPr>
-          <a:xfrm>
-            <a:off x="5495682" y="2950000"/>
-            <a:ext cx="1200000" cy="1200000"/>
-          </a:xfrm>
-          <a:prstGeom prst="rect">
-            <a:avLst/>
-          </a:prstGeom>
-        </p:spPr>
-      </p:pic>
-      <p:sp>
-        <p:nvSpPr>
-          <p:cNvPr id="12" name="Oval 11"/>
-          <p:cNvSpPr/>
-          <p:nvPr/>
-        </p:nvSpPr>
-        <p:spPr>
-          <a:xfrm>
-            <a:off x="5495682" y="2950000"/>
-            <a:ext cx="1200000" cy="1200000"/>
-          </a:xfrm>
-          <a:prstGeom prst="ellipse">
-            <a:avLst/>
-          </a:prstGeom>
-          <a:noFill/>
-          <a:ln w="38100">
-            <a:solidFill>
-              <a:srgbClr val="D4AF37"/>
-            </a:solidFill>
-          </a:ln>
-        </p:spPr>
-        <p:style>
-          <a:lnRef idx="1">
-            <a:schemeClr val="accent1"/>
-          </a:lnRef>
-          <a:fillRef idx="3">
-            <a:schemeClr val="accent1"/>
-          </a:fillRef>
-          <a:effectRef idx="2">
-            <a:schemeClr val="accent1"/>
-          </a:effectRef>
-          <a:fontRef idx="minor">
-            <a:schemeClr val="lt1"/>
-          </a:fontRef>
-        </p:style>
-        <p:txBody>
-          <a:bodyPr rtlCol="0" anchor="ctr"/>
-          <a:lstStyle/>
-          <a:p>
-            <a:pPr algn="ctr"/>
-          </a:p>
-        </p:txBody>
-      </p:sp>
-      <p:sp>
-        <p:nvSpPr>
-          <p:cNvPr id="13" name="TextBox 12"/>
+      <p:sp>
+        <p:nvSpPr>
+          <p:cNvPr id="11" name="TextBox 10"/>
           <p:cNvSpPr txBox="1"/>
           <p:nvPr/>
         </p:nvSpPr>
@@ -3551,7 +3484,7 @@
       </p:sp>
       <p:sp>
         <p:nvSpPr>
-          <p:cNvPr id="14" name="TextBox 13"/>
+          <p:cNvPr id="12" name="TextBox 11"/>
           <p:cNvSpPr txBox="1"/>
           <p:nvPr/>
         </p:nvSpPr>
@@ -3587,7 +3520,7 @@
       </p:sp>
       <p:sp>
         <p:nvSpPr>
-          <p:cNvPr id="15" name="TextBox 14"/>
+          <p:cNvPr id="13" name="TextBox 12"/>
           <p:cNvSpPr txBox="1"/>
           <p:nvPr/>
         </p:nvSpPr>
@@ -3623,7 +3556,7 @@
       </p:sp>
       <p:sp>
         <p:nvSpPr>
-          <p:cNvPr id="16" name="TextBox 15"/>
+          <p:cNvPr id="14" name="TextBox 13"/>
           <p:cNvSpPr txBox="1"/>
           <p:nvPr/>
         </p:nvSpPr>
@@ -3659,7 +3592,7 @@
       </p:sp>
       <p:sp>
         <p:nvSpPr>
-          <p:cNvPr id="17" name="TextBox 16"/>
+          <p:cNvPr id="15" name="TextBox 14"/>
           <p:cNvSpPr txBox="1"/>
           <p:nvPr/>
         </p:nvSpPr>
@@ -3695,7 +3628,7 @@
       </p:sp>
       <p:sp>
         <p:nvSpPr>
-          <p:cNvPr id="18" name="Rounded Rectangle 17"/>
+          <p:cNvPr id="16" name="Rounded Rectangle 15"/>
           <p:cNvSpPr/>
           <p:nvPr/>
         </p:nvSpPr>
@@ -3742,7 +3675,7 @@
       </p:sp>
       <p:sp>
         <p:nvSpPr>
-          <p:cNvPr id="19" name="Rectangle 18"/>
+          <p:cNvPr id="17" name="Rectangle 16"/>
           <p:cNvSpPr/>
           <p:nvPr/>
         </p:nvSpPr>
@@ -3785,7 +3718,7 @@
       </p:sp>
       <p:sp>
         <p:nvSpPr>
-          <p:cNvPr id="20" name="TextBox 19"/>
+          <p:cNvPr id="18" name="TextBox 17"/>
           <p:cNvSpPr txBox="1"/>
           <p:nvPr/>
         </p:nvSpPr>
@@ -4698,371 +4631,16 @@
           </a:p>
         </p:txBody>
       </p:sp>
-      <p:pic>
-        <p:nvPicPr>
-          <p:cNvPr id="7" name="Picture 6" descr="285d1b8cc9e3bb597bb381e7e545907.jpg"/>
-          <p:cNvPicPr>
-            <a:picLocks noChangeAspect="1"/>
-          </p:cNvPicPr>
-          <p:nvPr/>
-        </p:nvPicPr>
-        <p:blipFill>
-          <a:blip r:embed="rId3"/>
-          <a:stretch>
-            <a:fillRect/>
-          </a:stretch>
-        </p:blipFill>
-        <p:spPr>
-          <a:xfrm>
-            <a:off x="1550000" y="1500000"/>
-            <a:ext cx="1700000" cy="1700000"/>
-          </a:xfrm>
-          <a:prstGeom prst="rect">
-            <a:avLst/>
-          </a:prstGeom>
-        </p:spPr>
-      </p:pic>
-      <p:sp>
-        <p:nvSpPr>
-          <p:cNvPr id="8" name="Oval 7"/>
+      <p:sp>
+        <p:nvSpPr>
+          <p:cNvPr id="7" name="Rectangle 6"/>
           <p:cNvSpPr/>
           <p:nvPr/>
         </p:nvSpPr>
         <p:spPr>
           <a:xfrm>
-            <a:off x="1550000" y="1500000"/>
-            <a:ext cx="1700000" cy="1700000"/>
-          </a:xfrm>
-          <a:prstGeom prst="ellipse">
-            <a:avLst/>
-          </a:prstGeom>
-          <a:noFill/>
-          <a:ln w="50800">
-            <a:solidFill>
-              <a:srgbClr val="CD2026"/>
-            </a:solidFill>
-          </a:ln>
-        </p:spPr>
-        <p:style>
-          <a:lnRef idx="1">
-            <a:schemeClr val="accent1"/>
-          </a:lnRef>
-          <a:fillRef idx="3">
-            <a:schemeClr val="accent1"/>
-          </a:fillRef>
-          <a:effectRef idx="2">
-            <a:schemeClr val="accent1"/>
-          </a:effectRef>
-          <a:fontRef idx="minor">
-            <a:schemeClr val="lt1"/>
-          </a:fontRef>
-        </p:style>
-        <p:txBody>
-          <a:bodyPr rtlCol="0" anchor="ctr"/>
-          <a:lstStyle/>
-          <a:p>
-            <a:pPr algn="ctr"/>
-          </a:p>
-        </p:txBody>
-      </p:sp>
-      <p:sp>
-        <p:nvSpPr>
-          <p:cNvPr id="9" name="TextBox 8"/>
-          <p:cNvSpPr txBox="1"/>
-          <p:nvPr/>
-        </p:nvSpPr>
-        <p:spPr>
-          <a:xfrm>
-            <a:off x="1550000" y="2400000"/>
-            <a:ext cx="1700000" cy="280000"/>
-          </a:xfrm>
-          <a:prstGeom prst="rect">
-            <a:avLst/>
-          </a:prstGeom>
-          <a:noFill/>
-        </p:spPr>
-        <p:txBody>
-          <a:bodyPr wrap="square">
-            <a:spAutoFit/>
-          </a:bodyPr>
-          <a:lstStyle/>
-          <a:p>
-            <a:pPr algn="ctr">
-              <a:defRPr sz="1400" b="0">
-                <a:solidFill>
-                  <a:srgbClr val="D4AF37"/>
-                </a:solidFill>
-                <a:latin typeface="Microsoft YaHei"/>
-              </a:defRPr>
-            </a:pPr>
-            <a:r>
-              <a:t>Ding Dongxu</a:t>
-            </a:r>
-          </a:p>
-        </p:txBody>
-      </p:sp>
-      <p:sp>
-        <p:nvSpPr>
-          <p:cNvPr id="10" name="TextBox 9"/>
-          <p:cNvSpPr txBox="1"/>
-          <p:nvPr/>
-        </p:nvSpPr>
-        <p:spPr>
-          <a:xfrm>
-            <a:off x="1550000" y="2680000"/>
-            <a:ext cx="1700000" cy="200000"/>
-          </a:xfrm>
-          <a:prstGeom prst="rect">
-            <a:avLst/>
-          </a:prstGeom>
-          <a:noFill/>
-        </p:spPr>
-        <p:txBody>
-          <a:bodyPr wrap="square">
-            <a:spAutoFit/>
-          </a:bodyPr>
-          <a:lstStyle/>
-          <a:p>
-            <a:pPr algn="ctr">
-              <a:defRPr sz="1200" b="0">
-                <a:solidFill>
-                  <a:srgbClr val="C8C8D2"/>
-                </a:solidFill>
-                <a:latin typeface="Microsoft YaHei"/>
-              </a:defRPr>
-            </a:pPr>
-            <a:r>
-              <a:t>1970 -</a:t>
-            </a:r>
-          </a:p>
-        </p:txBody>
-      </p:sp>
-      <p:sp>
-        <p:nvSpPr>
-          <p:cNvPr id="11" name="TextBox 10"/>
-          <p:cNvSpPr txBox="1"/>
-          <p:nvPr/>
-        </p:nvSpPr>
-        <p:spPr>
-          <a:xfrm>
-            <a:off x="500000" y="3650000"/>
-            <a:ext cx="3800000" cy="200000"/>
-          </a:xfrm>
-          <a:prstGeom prst="rect">
-            <a:avLst/>
-          </a:prstGeom>
-          <a:noFill/>
-        </p:spPr>
-        <p:txBody>
-          <a:bodyPr wrap="square">
-            <a:spAutoFit/>
-          </a:bodyPr>
-          <a:lstStyle/>
-          <a:p>
-            <a:pPr algn="ctr">
-              <a:defRPr sz="1300" b="1">
-                <a:solidFill>
-                  <a:srgbClr val="D4AF37"/>
-                </a:solidFill>
-                <a:latin typeface="Microsoft YaHei"/>
-              </a:defRPr>
-            </a:pPr>
-            <a:r>
-              <a:t>教育背景  Education</a:t>
-            </a:r>
-          </a:p>
-        </p:txBody>
-      </p:sp>
-      <p:sp>
-        <p:nvSpPr>
-          <p:cNvPr id="12" name="TextBox 11"/>
-          <p:cNvSpPr txBox="1"/>
-          <p:nvPr/>
-        </p:nvSpPr>
-        <p:spPr>
-          <a:xfrm>
-            <a:off x="500000" y="3900000"/>
-            <a:ext cx="3800000" cy="220000"/>
-          </a:xfrm>
-          <a:prstGeom prst="rect">
-            <a:avLst/>
-          </a:prstGeom>
-          <a:noFill/>
-        </p:spPr>
-        <p:txBody>
-          <a:bodyPr wrap="square">
-            <a:spAutoFit/>
-          </a:bodyPr>
-          <a:lstStyle/>
-          <a:p>
-            <a:pPr algn="l">
-              <a:defRPr sz="1100" b="0">
-                <a:solidFill>
-                  <a:srgbClr val="EBEBF0"/>
-                </a:solidFill>
-                <a:latin typeface="Microsoft YaHei"/>
-              </a:defRPr>
-            </a:pPr>
-            <a:r>
-              <a:t>▸  西安航空学院  Xi'an Aviation College</a:t>
-            </a:r>
-          </a:p>
-        </p:txBody>
-      </p:sp>
-      <p:sp>
-        <p:nvSpPr>
-          <p:cNvPr id="13" name="TextBox 12"/>
-          <p:cNvSpPr txBox="1"/>
-          <p:nvPr/>
-        </p:nvSpPr>
-        <p:spPr>
-          <a:xfrm>
-            <a:off x="500000" y="4150000"/>
-            <a:ext cx="3800000" cy="220000"/>
-          </a:xfrm>
-          <a:prstGeom prst="rect">
-            <a:avLst/>
-          </a:prstGeom>
-          <a:noFill/>
-        </p:spPr>
-        <p:txBody>
-          <a:bodyPr wrap="square">
-            <a:spAutoFit/>
-          </a:bodyPr>
-          <a:lstStyle/>
-          <a:p>
-            <a:pPr algn="l">
-              <a:defRPr sz="1100" b="0">
-                <a:solidFill>
-                  <a:srgbClr val="EBEBF0"/>
-                </a:solidFill>
-                <a:latin typeface="Microsoft YaHei"/>
-              </a:defRPr>
-            </a:pPr>
-            <a:r>
-              <a:t>▸  上海交通大学硕士  SJTU Master</a:t>
-            </a:r>
-          </a:p>
-        </p:txBody>
-      </p:sp>
-      <p:sp>
-        <p:nvSpPr>
-          <p:cNvPr id="14" name="TextBox 13"/>
-          <p:cNvSpPr txBox="1"/>
-          <p:nvPr/>
-        </p:nvSpPr>
-        <p:spPr>
-          <a:xfrm>
-            <a:off x="500000" y="4400000"/>
-            <a:ext cx="3800000" cy="220000"/>
-          </a:xfrm>
-          <a:prstGeom prst="rect">
-            <a:avLst/>
-          </a:prstGeom>
-          <a:noFill/>
-        </p:spPr>
-        <p:txBody>
-          <a:bodyPr wrap="square">
-            <a:spAutoFit/>
-          </a:bodyPr>
-          <a:lstStyle/>
-          <a:p>
-            <a:pPr algn="l">
-              <a:defRPr sz="1100" b="0">
-                <a:solidFill>
-                  <a:srgbClr val="EBEBF0"/>
-                </a:solidFill>
-                <a:latin typeface="Microsoft YaHei"/>
-              </a:defRPr>
-            </a:pPr>
-            <a:r>
-              <a:t>▸  哈佛大学博士  Harvard Ph.D.</a:t>
-            </a:r>
-          </a:p>
-        </p:txBody>
-      </p:sp>
-      <p:sp>
-        <p:nvSpPr>
-          <p:cNvPr id="15" name="TextBox 14"/>
-          <p:cNvSpPr txBox="1"/>
-          <p:nvPr/>
-        </p:nvSpPr>
-        <p:spPr>
-          <a:xfrm>
-            <a:off x="4800000" y="500000"/>
-            <a:ext cx="6991365" cy="400000"/>
-          </a:xfrm>
-          <a:prstGeom prst="rect">
-            <a:avLst/>
-          </a:prstGeom>
-          <a:noFill/>
-        </p:spPr>
-        <p:txBody>
-          <a:bodyPr wrap="square">
-            <a:spAutoFit/>
-          </a:bodyPr>
-          <a:lstStyle/>
-          <a:p>
-            <a:pPr algn="l">
-              <a:defRPr sz="3000" b="1">
-                <a:solidFill>
-                  <a:srgbClr val="FFFFFF"/>
-                </a:solidFill>
-                <a:latin typeface="Microsoft YaHei"/>
-              </a:defRPr>
-            </a:pPr>
-            <a:r>
-              <a:t>从政经历</a:t>
-            </a:r>
-          </a:p>
-        </p:txBody>
-      </p:sp>
-      <p:sp>
-        <p:nvSpPr>
-          <p:cNvPr id="16" name="TextBox 15"/>
-          <p:cNvSpPr txBox="1"/>
-          <p:nvPr/>
-        </p:nvSpPr>
-        <p:spPr>
-          <a:xfrm>
-            <a:off x="4800000" y="880000"/>
-            <a:ext cx="6991365" cy="250000"/>
-          </a:xfrm>
-          <a:prstGeom prst="rect">
-            <a:avLst/>
-          </a:prstGeom>
-          <a:noFill/>
-        </p:spPr>
-        <p:txBody>
-          <a:bodyPr wrap="square">
-            <a:spAutoFit/>
-          </a:bodyPr>
-          <a:lstStyle/>
-          <a:p>
-            <a:pPr algn="l">
-              <a:defRPr sz="1400" b="0">
-                <a:solidFill>
-                  <a:srgbClr val="D4AF37"/>
-                </a:solidFill>
-                <a:latin typeface="Microsoft YaHei"/>
-              </a:defRPr>
-            </a:pPr>
-            <a:r>
-              <a:t>POLITICAL CAREER</a:t>
-            </a:r>
-          </a:p>
-        </p:txBody>
-      </p:sp>
-      <p:sp>
-        <p:nvSpPr>
-          <p:cNvPr id="17" name="Rectangle 16"/>
-          <p:cNvSpPr/>
-          <p:nvPr/>
-        </p:nvSpPr>
-        <p:spPr>
-          <a:xfrm>
-            <a:off x="4800000" y="1180000"/>
-            <a:ext cx="600000" cy="5000"/>
+            <a:off x="2300000" y="1300000"/>
+            <a:ext cx="800000" cy="5000"/>
           </a:xfrm>
           <a:prstGeom prst="rect">
             <a:avLst/>
@@ -5098,14 +4676,383 @@
       </p:sp>
       <p:sp>
         <p:nvSpPr>
+          <p:cNvPr id="8" name="Oval 7"/>
+          <p:cNvSpPr/>
+          <p:nvPr/>
+        </p:nvSpPr>
+        <p:spPr>
+          <a:xfrm>
+            <a:off x="1550000" y="1500000"/>
+            <a:ext cx="1700000" cy="1700000"/>
+          </a:xfrm>
+          <a:prstGeom prst="ellipse">
+            <a:avLst/>
+          </a:prstGeom>
+          <a:solidFill>
+            <a:srgbClr val="1E1E3C"/>
+          </a:solidFill>
+          <a:ln w="50800">
+            <a:solidFill>
+              <a:srgbClr val="CD2026"/>
+            </a:solidFill>
+          </a:ln>
+        </p:spPr>
+        <p:style>
+          <a:lnRef idx="1">
+            <a:schemeClr val="accent1"/>
+          </a:lnRef>
+          <a:fillRef idx="3">
+            <a:schemeClr val="accent1"/>
+          </a:fillRef>
+          <a:effectRef idx="2">
+            <a:schemeClr val="accent1"/>
+          </a:effectRef>
+          <a:fontRef idx="minor">
+            <a:schemeClr val="lt1"/>
+          </a:fontRef>
+        </p:style>
+        <p:txBody>
+          <a:bodyPr rtlCol="0" anchor="ctr"/>
+          <a:lstStyle/>
+          <a:p>
+            <a:pPr algn="ctr"/>
+          </a:p>
+        </p:txBody>
+      </p:sp>
+      <p:sp>
+        <p:nvSpPr>
+          <p:cNvPr id="9" name="TextBox 8"/>
+          <p:cNvSpPr txBox="1"/>
+          <p:nvPr/>
+        </p:nvSpPr>
+        <p:spPr>
+          <a:xfrm>
+            <a:off x="1550000" y="2000000"/>
+            <a:ext cx="1700000" cy="400000"/>
+          </a:xfrm>
+          <a:prstGeom prst="rect">
+            <a:avLst/>
+          </a:prstGeom>
+          <a:noFill/>
+        </p:spPr>
+        <p:txBody>
+          <a:bodyPr wrap="square">
+            <a:spAutoFit/>
+          </a:bodyPr>
+          <a:lstStyle/>
+          <a:p>
+            <a:pPr algn="ctr">
+              <a:defRPr sz="2600" b="1">
+                <a:solidFill>
+                  <a:srgbClr val="FFFFFF"/>
+                </a:solidFill>
+                <a:latin typeface="Microsoft YaHei"/>
+              </a:defRPr>
+            </a:pPr>
+            <a:r>
+              <a:t>丁东旭</a:t>
+            </a:r>
+          </a:p>
+        </p:txBody>
+      </p:sp>
+      <p:sp>
+        <p:nvSpPr>
+          <p:cNvPr id="10" name="TextBox 9"/>
+          <p:cNvSpPr txBox="1"/>
+          <p:nvPr/>
+        </p:nvSpPr>
+        <p:spPr>
+          <a:xfrm>
+            <a:off x="1550000" y="2400000"/>
+            <a:ext cx="1700000" cy="280000"/>
+          </a:xfrm>
+          <a:prstGeom prst="rect">
+            <a:avLst/>
+          </a:prstGeom>
+          <a:noFill/>
+        </p:spPr>
+        <p:txBody>
+          <a:bodyPr wrap="square">
+            <a:spAutoFit/>
+          </a:bodyPr>
+          <a:lstStyle/>
+          <a:p>
+            <a:pPr algn="ctr">
+              <a:defRPr sz="1400" b="0">
+                <a:solidFill>
+                  <a:srgbClr val="D4AF37"/>
+                </a:solidFill>
+                <a:latin typeface="Microsoft YaHei"/>
+              </a:defRPr>
+            </a:pPr>
+            <a:r>
+              <a:t>Ding Dongxu</a:t>
+            </a:r>
+          </a:p>
+        </p:txBody>
+      </p:sp>
+      <p:sp>
+        <p:nvSpPr>
+          <p:cNvPr id="11" name="TextBox 10"/>
+          <p:cNvSpPr txBox="1"/>
+          <p:nvPr/>
+        </p:nvSpPr>
+        <p:spPr>
+          <a:xfrm>
+            <a:off x="1550000" y="2680000"/>
+            <a:ext cx="1700000" cy="200000"/>
+          </a:xfrm>
+          <a:prstGeom prst="rect">
+            <a:avLst/>
+          </a:prstGeom>
+          <a:noFill/>
+        </p:spPr>
+        <p:txBody>
+          <a:bodyPr wrap="square">
+            <a:spAutoFit/>
+          </a:bodyPr>
+          <a:lstStyle/>
+          <a:p>
+            <a:pPr algn="ctr">
+              <a:defRPr sz="1200" b="0">
+                <a:solidFill>
+                  <a:srgbClr val="C8C8D2"/>
+                </a:solidFill>
+                <a:latin typeface="Microsoft YaHei"/>
+              </a:defRPr>
+            </a:pPr>
+            <a:r>
+              <a:t>1970 -</a:t>
+            </a:r>
+          </a:p>
+        </p:txBody>
+      </p:sp>
+      <p:sp>
+        <p:nvSpPr>
+          <p:cNvPr id="12" name="TextBox 11"/>
+          <p:cNvSpPr txBox="1"/>
+          <p:nvPr/>
+        </p:nvSpPr>
+        <p:spPr>
+          <a:xfrm>
+            <a:off x="500000" y="3650000"/>
+            <a:ext cx="3800000" cy="200000"/>
+          </a:xfrm>
+          <a:prstGeom prst="rect">
+            <a:avLst/>
+          </a:prstGeom>
+          <a:noFill/>
+        </p:spPr>
+        <p:txBody>
+          <a:bodyPr wrap="square">
+            <a:spAutoFit/>
+          </a:bodyPr>
+          <a:lstStyle/>
+          <a:p>
+            <a:pPr algn="ctr">
+              <a:defRPr sz="1300" b="1">
+                <a:solidFill>
+                  <a:srgbClr val="D4AF37"/>
+                </a:solidFill>
+                <a:latin typeface="Microsoft YaHei"/>
+              </a:defRPr>
+            </a:pPr>
+            <a:r>
+              <a:t>教育背景  Education</a:t>
+            </a:r>
+          </a:p>
+        </p:txBody>
+      </p:sp>
+      <p:sp>
+        <p:nvSpPr>
+          <p:cNvPr id="13" name="TextBox 12"/>
+          <p:cNvSpPr txBox="1"/>
+          <p:nvPr/>
+        </p:nvSpPr>
+        <p:spPr>
+          <a:xfrm>
+            <a:off x="500000" y="3900000"/>
+            <a:ext cx="3800000" cy="220000"/>
+          </a:xfrm>
+          <a:prstGeom prst="rect">
+            <a:avLst/>
+          </a:prstGeom>
+          <a:noFill/>
+        </p:spPr>
+        <p:txBody>
+          <a:bodyPr wrap="square">
+            <a:spAutoFit/>
+          </a:bodyPr>
+          <a:lstStyle/>
+          <a:p>
+            <a:pPr algn="l">
+              <a:defRPr sz="1100" b="0">
+                <a:solidFill>
+                  <a:srgbClr val="EBEBF0"/>
+                </a:solidFill>
+                <a:latin typeface="Microsoft YaHei"/>
+              </a:defRPr>
+            </a:pPr>
+            <a:r>
+              <a:t>▸  西安航空学院  Xi'an Aviation College</a:t>
+            </a:r>
+          </a:p>
+        </p:txBody>
+      </p:sp>
+      <p:sp>
+        <p:nvSpPr>
+          <p:cNvPr id="14" name="TextBox 13"/>
+          <p:cNvSpPr txBox="1"/>
+          <p:nvPr/>
+        </p:nvSpPr>
+        <p:spPr>
+          <a:xfrm>
+            <a:off x="500000" y="4150000"/>
+            <a:ext cx="3800000" cy="220000"/>
+          </a:xfrm>
+          <a:prstGeom prst="rect">
+            <a:avLst/>
+          </a:prstGeom>
+          <a:noFill/>
+        </p:spPr>
+        <p:txBody>
+          <a:bodyPr wrap="square">
+            <a:spAutoFit/>
+          </a:bodyPr>
+          <a:lstStyle/>
+          <a:p>
+            <a:pPr algn="l">
+              <a:defRPr sz="1100" b="0">
+                <a:solidFill>
+                  <a:srgbClr val="EBEBF0"/>
+                </a:solidFill>
+                <a:latin typeface="Microsoft YaHei"/>
+              </a:defRPr>
+            </a:pPr>
+            <a:r>
+              <a:t>▸  上海交通大学硕士  SJTU Master</a:t>
+            </a:r>
+          </a:p>
+        </p:txBody>
+      </p:sp>
+      <p:sp>
+        <p:nvSpPr>
+          <p:cNvPr id="15" name="TextBox 14"/>
+          <p:cNvSpPr txBox="1"/>
+          <p:nvPr/>
+        </p:nvSpPr>
+        <p:spPr>
+          <a:xfrm>
+            <a:off x="500000" y="4400000"/>
+            <a:ext cx="3800000" cy="220000"/>
+          </a:xfrm>
+          <a:prstGeom prst="rect">
+            <a:avLst/>
+          </a:prstGeom>
+          <a:noFill/>
+        </p:spPr>
+        <p:txBody>
+          <a:bodyPr wrap="square">
+            <a:spAutoFit/>
+          </a:bodyPr>
+          <a:lstStyle/>
+          <a:p>
+            <a:pPr algn="l">
+              <a:defRPr sz="1100" b="0">
+                <a:solidFill>
+                  <a:srgbClr val="EBEBF0"/>
+                </a:solidFill>
+                <a:latin typeface="Microsoft YaHei"/>
+              </a:defRPr>
+            </a:pPr>
+            <a:r>
+              <a:t>▸  哈佛大学博士  Harvard Ph.D.</a:t>
+            </a:r>
+          </a:p>
+        </p:txBody>
+      </p:sp>
+      <p:sp>
+        <p:nvSpPr>
+          <p:cNvPr id="16" name="TextBox 15"/>
+          <p:cNvSpPr txBox="1"/>
+          <p:nvPr/>
+        </p:nvSpPr>
+        <p:spPr>
+          <a:xfrm>
+            <a:off x="4800000" y="500000"/>
+            <a:ext cx="6991365" cy="400000"/>
+          </a:xfrm>
+          <a:prstGeom prst="rect">
+            <a:avLst/>
+          </a:prstGeom>
+          <a:noFill/>
+        </p:spPr>
+        <p:txBody>
+          <a:bodyPr wrap="square">
+            <a:spAutoFit/>
+          </a:bodyPr>
+          <a:lstStyle/>
+          <a:p>
+            <a:pPr algn="l">
+              <a:defRPr sz="3000" b="1">
+                <a:solidFill>
+                  <a:srgbClr val="FFFFFF"/>
+                </a:solidFill>
+                <a:latin typeface="Microsoft YaHei"/>
+              </a:defRPr>
+            </a:pPr>
+            <a:r>
+              <a:t>从政经历</a:t>
+            </a:r>
+          </a:p>
+        </p:txBody>
+      </p:sp>
+      <p:sp>
+        <p:nvSpPr>
+          <p:cNvPr id="17" name="TextBox 16"/>
+          <p:cNvSpPr txBox="1"/>
+          <p:nvPr/>
+        </p:nvSpPr>
+        <p:spPr>
+          <a:xfrm>
+            <a:off x="4800000" y="880000"/>
+            <a:ext cx="6991365" cy="250000"/>
+          </a:xfrm>
+          <a:prstGeom prst="rect">
+            <a:avLst/>
+          </a:prstGeom>
+          <a:noFill/>
+        </p:spPr>
+        <p:txBody>
+          <a:bodyPr wrap="square">
+            <a:spAutoFit/>
+          </a:bodyPr>
+          <a:lstStyle/>
+          <a:p>
+            <a:pPr algn="l">
+              <a:defRPr sz="1400" b="0">
+                <a:solidFill>
+                  <a:srgbClr val="D4AF37"/>
+                </a:solidFill>
+                <a:latin typeface="Microsoft YaHei"/>
+              </a:defRPr>
+            </a:pPr>
+            <a:r>
+              <a:t>POLITICAL CAREER</a:t>
+            </a:r>
+          </a:p>
+        </p:txBody>
+      </p:sp>
+      <p:sp>
+        <p:nvSpPr>
           <p:cNvPr id="18" name="Rectangle 17"/>
           <p:cNvSpPr/>
           <p:nvPr/>
         </p:nvSpPr>
         <p:spPr>
           <a:xfrm>
-            <a:off x="4950000" y="1450000"/>
-            <a:ext cx="4000" cy="4700000"/>
+            <a:off x="4800000" y="1180000"/>
+            <a:ext cx="600000" cy="5000"/>
           </a:xfrm>
           <a:prstGeom prst="rect">
             <a:avLst/>
@@ -5141,7 +5088,50 @@
       </p:sp>
       <p:sp>
         <p:nvSpPr>
-          <p:cNvPr id="19" name="Oval 18"/>
+          <p:cNvPr id="19" name="Rectangle 18"/>
+          <p:cNvSpPr/>
+          <p:nvPr/>
+        </p:nvSpPr>
+        <p:spPr>
+          <a:xfrm>
+            <a:off x="4950000" y="1450000"/>
+            <a:ext cx="4000" cy="4700000"/>
+          </a:xfrm>
+          <a:prstGeom prst="rect">
+            <a:avLst/>
+          </a:prstGeom>
+          <a:solidFill>
+            <a:srgbClr val="CD2026"/>
+          </a:solidFill>
+          <a:ln>
+            <a:noFill/>
+          </a:ln>
+        </p:spPr>
+        <p:style>
+          <a:lnRef idx="1">
+            <a:schemeClr val="accent1"/>
+          </a:lnRef>
+          <a:fillRef idx="3">
+            <a:schemeClr val="accent1"/>
+          </a:fillRef>
+          <a:effectRef idx="2">
+            <a:schemeClr val="accent1"/>
+          </a:effectRef>
+          <a:fontRef idx="minor">
+            <a:schemeClr val="lt1"/>
+          </a:fontRef>
+        </p:style>
+        <p:txBody>
+          <a:bodyPr rtlCol="0" anchor="ctr"/>
+          <a:lstStyle/>
+          <a:p>
+            <a:pPr algn="ctr"/>
+          </a:p>
+        </p:txBody>
+      </p:sp>
+      <p:sp>
+        <p:nvSpPr>
+          <p:cNvPr id="20" name="Oval 19"/>
           <p:cNvSpPr/>
           <p:nvPr/>
         </p:nvSpPr>
@@ -5184,7 +5174,7 @@
       </p:sp>
       <p:sp>
         <p:nvSpPr>
-          <p:cNvPr id="20" name="TextBox 19"/>
+          <p:cNvPr id="21" name="TextBox 20"/>
           <p:cNvSpPr txBox="1"/>
           <p:nvPr/>
         </p:nvSpPr>
@@ -5220,7 +5210,7 @@
       </p:sp>
       <p:sp>
         <p:nvSpPr>
-          <p:cNvPr id="21" name="TextBox 20"/>
+          <p:cNvPr id="22" name="TextBox 21"/>
           <p:cNvSpPr txBox="1"/>
           <p:nvPr/>
         </p:nvSpPr>
@@ -5256,7 +5246,7 @@
       </p:sp>
       <p:sp>
         <p:nvSpPr>
-          <p:cNvPr id="22" name="TextBox 21"/>
+          <p:cNvPr id="23" name="TextBox 22"/>
           <p:cNvSpPr txBox="1"/>
           <p:nvPr/>
         </p:nvSpPr>
@@ -5292,7 +5282,7 @@
       </p:sp>
       <p:sp>
         <p:nvSpPr>
-          <p:cNvPr id="23" name="Oval 22"/>
+          <p:cNvPr id="24" name="Oval 23"/>
           <p:cNvSpPr/>
           <p:nvPr/>
         </p:nvSpPr>
@@ -5335,7 +5325,7 @@
       </p:sp>
       <p:sp>
         <p:nvSpPr>
-          <p:cNvPr id="24" name="TextBox 23"/>
+          <p:cNvPr id="25" name="TextBox 24"/>
           <p:cNvSpPr txBox="1"/>
           <p:nvPr/>
         </p:nvSpPr>
@@ -5371,7 +5361,7 @@
       </p:sp>
       <p:sp>
         <p:nvSpPr>
-          <p:cNvPr id="25" name="TextBox 24"/>
+          <p:cNvPr id="26" name="TextBox 25"/>
           <p:cNvSpPr txBox="1"/>
           <p:nvPr/>
         </p:nvSpPr>
@@ -5407,7 +5397,7 @@
       </p:sp>
       <p:sp>
         <p:nvSpPr>
-          <p:cNvPr id="26" name="TextBox 25"/>
+          <p:cNvPr id="27" name="TextBox 26"/>
           <p:cNvSpPr txBox="1"/>
           <p:nvPr/>
         </p:nvSpPr>
@@ -5443,7 +5433,7 @@
       </p:sp>
       <p:sp>
         <p:nvSpPr>
-          <p:cNvPr id="27" name="Oval 26"/>
+          <p:cNvPr id="28" name="Oval 27"/>
           <p:cNvSpPr/>
           <p:nvPr/>
         </p:nvSpPr>
@@ -5486,7 +5476,7 @@
       </p:sp>
       <p:sp>
         <p:nvSpPr>
-          <p:cNvPr id="28" name="TextBox 27"/>
+          <p:cNvPr id="29" name="TextBox 28"/>
           <p:cNvSpPr txBox="1"/>
           <p:nvPr/>
         </p:nvSpPr>
@@ -5522,7 +5512,7 @@
       </p:sp>
       <p:sp>
         <p:nvSpPr>
-          <p:cNvPr id="29" name="TextBox 28"/>
+          <p:cNvPr id="30" name="TextBox 29"/>
           <p:cNvSpPr txBox="1"/>
           <p:nvPr/>
         </p:nvSpPr>
@@ -5558,7 +5548,7 @@
       </p:sp>
       <p:sp>
         <p:nvSpPr>
-          <p:cNvPr id="30" name="TextBox 29"/>
+          <p:cNvPr id="31" name="TextBox 30"/>
           <p:cNvSpPr txBox="1"/>
           <p:nvPr/>
         </p:nvSpPr>
@@ -5594,7 +5584,7 @@
       </p:sp>
       <p:sp>
         <p:nvSpPr>
-          <p:cNvPr id="31" name="Oval 30"/>
+          <p:cNvPr id="32" name="Oval 31"/>
           <p:cNvSpPr/>
           <p:nvPr/>
         </p:nvSpPr>
@@ -5637,7 +5627,7 @@
       </p:sp>
       <p:sp>
         <p:nvSpPr>
-          <p:cNvPr id="32" name="TextBox 31"/>
+          <p:cNvPr id="33" name="TextBox 32"/>
           <p:cNvSpPr txBox="1"/>
           <p:nvPr/>
         </p:nvSpPr>
@@ -5673,7 +5663,7 @@
       </p:sp>
       <p:sp>
         <p:nvSpPr>
-          <p:cNvPr id="33" name="TextBox 32"/>
+          <p:cNvPr id="34" name="TextBox 33"/>
           <p:cNvSpPr txBox="1"/>
           <p:nvPr/>
         </p:nvSpPr>
@@ -5709,7 +5699,7 @@
       </p:sp>
       <p:sp>
         <p:nvSpPr>
-          <p:cNvPr id="34" name="TextBox 33"/>
+          <p:cNvPr id="35" name="TextBox 34"/>
           <p:cNvSpPr txBox="1"/>
           <p:nvPr/>
         </p:nvSpPr>
@@ -5745,7 +5735,7 @@
       </p:sp>
       <p:sp>
         <p:nvSpPr>
-          <p:cNvPr id="35" name="Rectangle 34"/>
+          <p:cNvPr id="36" name="Rectangle 35"/>
           <p:cNvSpPr/>
           <p:nvPr/>
         </p:nvSpPr>

</xml_diff>